<commit_message>
docs(pptx): presenter names + Elastic Cloud migration updates
Slide 1: added presenters — אורלי בר • איריס המבר • זיו ורסנו
Slide 3: architecture labels → Elasticsearch/Elastic Cloud, Kibana/Cloud Dashboards
Slide 6: storage card → Elastic Cloud (managed, eu-central-1), 7M+ cloud counts
Slide 13: live numbers now from Elastic Cloud (2.9M bus / 1.9M train /
  592K traffic / 1.6M alerts / 7,046,031 total)
Slide 14: tech stack → Elasticsearch (Elastic Cloud)
Slide 16: ES-OOM challenge now shows its resolution (migration to cloud)
Formatting preserved (edits at run level / cloned rPr; RTL intact).

Co-Authored-By: Claude Opus 4.7 <noreply@anthropic.com>
</commit_message>
<xml_diff>
--- a/docs/Israel_Transit_Project_Presentation.pptx
+++ b/docs/Israel_Transit_Project_Presentation.pptx
@@ -3293,6 +3293,42 @@
           </a:p>
         </p:txBody>
       </p:sp>
+      <p:sp>
+        <p:nvSpPr>
+          <p:cNvPr id="6" name="TextBox 5"/>
+          <p:cNvSpPr txBox="1"/>
+          <p:nvPr/>
+        </p:nvSpPr>
+        <p:spPr>
+          <a:xfrm>
+            <a:off x="914400" y="5577840"/>
+            <a:ext cx="10058400" cy="457200"/>
+          </a:xfrm>
+          <a:prstGeom prst="rect">
+            <a:avLst/>
+          </a:prstGeom>
+          <a:noFill/>
+        </p:spPr>
+        <p:txBody>
+          <a:bodyPr wrap="square">
+            <a:spAutoFit/>
+          </a:bodyPr>
+          <a:lstStyle/>
+          <a:p>
+            <a:pPr algn="ctr">
+              <a:defRPr sz="1400" b="0">
+                <a:solidFill>
+                  <a:srgbClr val="FFFFFF"/>
+                </a:solidFill>
+                <a:latin typeface="Arial"/>
+              </a:defRPr>
+            </a:pPr>
+            <a:r>
+              <a:t>מגישות:  אורלי בר  •  איריס המבר  •  זיו ורסנו</a:t>
+            </a:r>
+          </a:p>
+        </p:txBody>
+      </p:sp>
     </p:spTree>
   </p:cSld>
   <p:clrMapOvr>
@@ -5086,7 +5122,7 @@
               </a:defRPr>
             </a:pPr>
             <a:r>
-              <a:t>מספרים מתוך ה-VM הפועל</a:t>
+              <a:t>מספרים מתוך Elastic Cloud (managed)</a:t>
             </a:r>
           </a:p>
         </p:txBody>
@@ -5203,7 +5239,7 @@
               </a:defRPr>
             </a:pPr>
             <a:r>
-              <a:t>268,771</a:t>
+              <a:t>2,917,758</a:t>
             </a:r>
           </a:p>
         </p:txBody>
@@ -5320,7 +5356,7 @@
               </a:defRPr>
             </a:pPr>
             <a:r>
-              <a:t>508,772</a:t>
+              <a:t>1,906,678</a:t>
             </a:r>
           </a:p>
         </p:txBody>
@@ -5437,7 +5473,7 @@
               </a:defRPr>
             </a:pPr>
             <a:r>
-              <a:t>67,423</a:t>
+              <a:t>591,661</a:t>
             </a:r>
           </a:p>
         </p:txBody>
@@ -5554,7 +5590,7 @@
               </a:defRPr>
             </a:pPr>
             <a:r>
-              <a:t>51,874</a:t>
+              <a:t>1,629,934</a:t>
             </a:r>
           </a:p>
         </p:txBody>
@@ -5590,7 +5626,7 @@
               </a:defRPr>
             </a:pPr>
             <a:r>
-              <a:t>עדכוני נסיעה</a:t>
+              <a:t>התראות שירות</a:t>
             </a:r>
           </a:p>
         </p:txBody>
@@ -5671,7 +5707,7 @@
               </a:defRPr>
             </a:pPr>
             <a:r>
-              <a:t>17,512</a:t>
+              <a:t>7,046,031</a:t>
             </a:r>
           </a:p>
         </p:txBody>
@@ -5707,7 +5743,7 @@
               </a:defRPr>
             </a:pPr>
             <a:r>
-              <a:t>התראות שירות</a:t>
+              <a:t>סה״כ בענן</a:t>
             </a:r>
           </a:p>
         </p:txBody>
@@ -7019,7 +7055,7 @@
             </a:r>
             <a:br/>
             <a:r>
-              <a:t>Elasticsearch 8.8</a:t>
+              <a:t>Elasticsearch (Elastic Cloud)</a:t>
             </a:r>
             <a:br/>
             <a:r>
@@ -9447,7 +9483,7 @@
               </a:defRPr>
             </a:pPr>
             <a:r>
-              <a:t>heap הורד ל-256-512MB, restart: no — נפתח רק למצגת</a:t>
+              <a:t>פתרון: הגירה ל-Elastic Cloud — 7M+ רשומות, אפס עומס על ה-VM</a:t>
             </a:r>
           </a:p>
         </p:txBody>
@@ -13583,7 +13619,7 @@
             </a:r>
             <a:br/>
             <a:r>
-              <a:t>Search Index</a:t>
+              <a:t>Elastic Cloud ☁️</a:t>
             </a:r>
           </a:p>
         </p:txBody>
@@ -13971,7 +14007,7 @@
             </a:r>
             <a:br/>
             <a:r>
-              <a:t>Dashboards</a:t>
+              <a:t>Cloud Dashboards</a:t>
             </a:r>
           </a:p>
         </p:txBody>
@@ -17534,7 +17570,7 @@
               </a:defRPr>
             </a:pPr>
             <a:r>
-              <a:t>Elasticsearch 8.8</a:t>
+              <a:t>Elasticsearch · Elastic Cloud ☁️</a:t>
             </a:r>
           </a:p>
         </p:txBody>
@@ -17570,33 +17606,39 @@
               </a:defRPr>
             </a:pPr>
             <a:r>
-              <a:t>Distributed Search Engine</a:t>
+              <a:t>Managed Service (Elastic Cloud)</a:t>
             </a:r>
             <a:br/>
+            <a:r>
+              <a:t>Region: eu-central-1 (AWS)</a:t>
+            </a:r>
             <a:br/>
             <a:r>
-              <a:t>transit-bus-positions: 268K docs</a:t>
+              <a:t/>
             </a:r>
             <a:br/>
             <a:r>
-              <a:t>transit-train-positions: 508K docs</a:t>
+              <a:t>transit-bus-positions: 2.9M</a:t>
             </a:r>
             <a:br/>
             <a:r>
-              <a:t>transit-traffic: 67K docs</a:t>
+              <a:t>transit-train-positions: 1.9M</a:t>
             </a:r>
             <a:br/>
             <a:r>
-              <a:t>transit-trip-updates: 51K docs</a:t>
+              <a:t>transit-traffic: 592K</a:t>
             </a:r>
             <a:br/>
             <a:r>
-              <a:t>transit-service-alerts: 17K docs</a:t>
+              <a:t>transit-service-alerts: 1.6M</a:t>
             </a:r>
             <a:br/>
+            <a:r>
+              <a:t/>
+            </a:r>
             <a:br/>
             <a:r>
-              <a:t>Heap: 256-512MB (מוטבל ל-VM)</a:t>
+              <a:t>סה״כ: 7M+ רשומות · אפס עומס VM</a:t>
             </a:r>
           </a:p>
         </p:txBody>

</xml_diff>